<commit_message>
Deck: plain-prose edit of slide text (no dashes, no slogan titles); content unchanged
Co-Authored-By: Claude Fable 5 <noreply@anthropic.com>
</commit_message>
<xml_diff>
--- a/SEEM_project_deck.pptx
+++ b/SEEM_project_deck.pptx
@@ -3204,7 +3204,7 @@
                 </a:solidFill>
                 <a:latin typeface="Calibri"/>
               </a:rPr>
-              <a:t>SEEM project status — September 4, 2026  (third pass; supersedes the August 6 deck)</a:t>
+              <a:t>SEEM project status, September 4, 2026  (third pass; supersedes the August 6 deck)</a:t>
             </a:r>
           </a:p>
         </p:txBody>
@@ -3290,7 +3290,7 @@
                 </a:solidFill>
                 <a:latin typeface="Calibri"/>
               </a:rPr>
-              <a:t>The acid test: simulating all 850 runs</a:t>
+              <a:t>Simulating all 850 runs</a:t>
             </a:r>
           </a:p>
         </p:txBody>
@@ -3372,7 +3372,7 @@
                 </a:solidFill>
                 <a:latin typeface="Calibri"/>
               </a:rPr>
-              <a:t>Three arms differ only in the size law: ceiling law, TPL, empirical resampling.  Stress–strain curves, yield overshoot across 256× in cooling rate, and flow stress (±5%) all emerge; yield-peak RMS 2.5% (ceiling), 1.4% (TPL), 0.9% (empirical).</a:t>
+              <a:t>Three arms differ only in the size law: ceiling law, TPL, empirical resampling.  Stress-strain curves, yield overshoot across 256× in cooling rate, and flow stress (±5%) all emerge; yield-peak RMS 2.5% (ceiling), 1.4% (TPL), 0.9% (empirical).</a:t>
             </a:r>
           </a:p>
         </p:txBody>
@@ -3427,7 +3427,7 @@
                 </a:solidFill>
                 <a:latin typeface="Calibri"/>
               </a:rPr>
-              <a:t>Takeaway — </a:t>
+              <a:t>Takeaway: </a:t>
             </a:r>
             <a:r>
               <a:rPr sz="1350" b="0">
@@ -3436,7 +3436,7 @@
                 </a:solidFill>
                 <a:latin typeface="Calibri"/>
               </a:rPr>
-              <a:t>The model predicts the yield strength of a glass from its preparation to a few percent — and macroscopic curves cannot tell size laws apart; the per-event likelihood can.</a:t>
+              <a:t>The model predicts the yield strength of a glass from its preparation to a few percent, and macroscopic curves cannot tell size laws apart. The per-event likelihood can.</a:t>
             </a:r>
           </a:p>
         </p:txBody>
@@ -3586,7 +3586,7 @@
                 </a:solidFill>
                 <a:latin typeface="Calibri"/>
               </a:rPr>
-              <a:t>The fields are preparation-blind by construction (one map for all histories) — so this is the missing state variable of the first pass, seen macroscopically</a:t>
+              <a:t>The fields are preparation-blind by construction (one map for all histories), so this is the missing state variable of the first pass, seen macroscopically</a:t>
             </a:r>
           </a:p>
           <a:p>
@@ -3658,7 +3658,7 @@
                 </a:solidFill>
                 <a:latin typeface="Calibri"/>
               </a:rPr>
-              <a:t>Takeaway — </a:t>
+              <a:t>Takeaway: </a:t>
             </a:r>
             <a:r>
               <a:rPr sz="1350" b="0">
@@ -3817,7 +3817,7 @@
                 </a:solidFill>
                 <a:latin typeface="Calibri"/>
               </a:rPr>
-              <a:t>Mean event size: 1.70× (β = −0.117 ± 0.005) — the ceiling memory, measured another way; it lives in the tail (geometric mean moves only 1.20×)</a:t>
+              <a:t>Mean event size: 1.70× (β = −0.117 ± 0.005), the ceiling memory measured another way; it lives in the tail (geometric mean moves only 1.20×)</a:t>
             </a:r>
           </a:p>
           <a:p>
@@ -3906,7 +3906,7 @@
                 </a:solidFill>
                 <a:latin typeface="Calibri"/>
               </a:rPr>
-              <a:t>Takeaway — </a:t>
+              <a:t>Takeaway: </a:t>
             </a:r>
             <a:r>
               <a:rPr sz="1350" b="0">
@@ -3915,7 +3915,7 @@
                 </a:solidFill>
                 <a:latin typeface="Calibri"/>
               </a:rPr>
-              <a:t>Memory acts through event size, not event rate — against the simplest one-variable STZ reading, where preparation enters through the STZ density.</a:t>
+              <a:t>Memory acts through event size, not event rate. That cuts against the simplest one-variable STZ reading, where preparation enters through the STZ density.</a:t>
             </a:r>
           </a:p>
         </p:txBody>
@@ -4120,7 +4120,7 @@
                 </a:solidFill>
                 <a:latin typeface="Calibri"/>
               </a:rPr>
-              <a:t>Takeaway — </a:t>
+              <a:t>Takeaway: </a:t>
             </a:r>
             <a:r>
               <a:rPr sz="1350" b="0">
@@ -4245,7 +4245,7 @@
                 </a:solidFill>
                 <a:latin typeface="Calibri"/>
               </a:rPr>
-              <a:t>Nine-rate regression with a fixed effect per (cell, strain window): β = −0.21 → −0.11 → −0.05 → −0.04 from γ ≈ 0.15 to 0.45, and it falls within fixed u bands — relaxation, not state dependence; γ_r ≈ 0.18</a:t>
+              <a:t>Nine-rate regression with a fixed effect per (cell, strain window): β = −0.21 → −0.11 → −0.05 → −0.04 from γ ≈ 0.15 to 0.45, and it falls within fixed u bands, so this is relaxation rather than state dependence; γ_r ≈ 0.18</a:t>
             </a:r>
           </a:p>
           <a:p>
@@ -4334,7 +4334,7 @@
                 </a:solidFill>
                 <a:latin typeface="Calibri"/>
               </a:rPr>
-              <a:t>Takeaway — </a:t>
+              <a:t>Takeaway: </a:t>
             </a:r>
             <a:r>
               <a:rPr sz="1350" b="0">
@@ -4343,7 +4343,7 @@
                 </a:solidFill>
                 <a:latin typeface="Calibri"/>
               </a:rPr>
-              <a:t>The third variable is not a frozen label: plastic strain erases it on a scale of a few tenths — now measured, not assumed.</a:t>
+              <a:t>The third variable is not a frozen label: plastic strain erases it on a scale of a few tenths, now measured, not assumed.</a:t>
             </a:r>
           </a:p>
         </p:txBody>
@@ -4459,7 +4459,7 @@
                 </a:solidFill>
                 <a:latin typeface="Calibri"/>
               </a:rPr>
-              <a:t>Parameter-free prediction: apply the between-preparation relation within a preparation — each trajectory gets exp(κ·δu₀) with κ = β·d ln(rate)/du₀ = −43</a:t>
+              <a:t>Parameter-free prediction: apply the between-preparation relation within a preparation, so each trajectory gets exp(κ·δu₀) with κ = β·d ln(rate)/du₀ = −43</a:t>
             </a:r>
           </a:p>
           <a:p>
@@ -4565,7 +4565,7 @@
                 </a:solidFill>
                 <a:latin typeface="Calibri"/>
               </a:rPr>
-              <a:t>Takeaway — </a:t>
+              <a:t>Takeaway: </a:t>
             </a:r>
             <a:r>
               <a:rPr sz="1350" b="0">
@@ -4707,7 +4707,7 @@
                 </a:solidFill>
                 <a:latin typeface="Calibri"/>
               </a:rPr>
-              <a:t>So does a true ceiling with m ≈ 2 at n ≈ 5,000 (green synthetics: c/s_max 1.02–1.12)</a:t>
+              <a:t>So does a true ceiling with m ≈ 2 at n ≈ 5,000 (green synthetics: c/s_max 1.02 to 1.12)</a:t>
             </a:r>
           </a:p>
           <a:p>
@@ -4724,7 +4724,7 @@
                 </a:solidFill>
                 <a:latin typeface="Calibri"/>
               </a:rPr>
-              <a:t>A true TPL under the same fit runs off to 3–350× the maximum and collapses on refit (blue)</a:t>
+              <a:t>A true TPL under the same fit runs off to 3 to 350× the maximum and collapses on refit (blue)</a:t>
             </a:r>
           </a:p>
           <a:p>
@@ -4741,7 +4741,7 @@
                 </a:solidFill>
                 <a:latin typeface="Calibri"/>
               </a:rPr>
-              <a:t>Merging consecutive drop steps into single avalanches (187k → 172k): the ceiling law wins by more (ΔAIC 117–213), s_c moves &lt; 2%, k shifts +0.05</a:t>
+              <a:t>Merging consecutive drop steps into single avalanches (187k → 172k): the ceiling law wins by more (ΔAIC 117 to 213), s_c moves &lt; 2%, k shifts +0.05</a:t>
             </a:r>
           </a:p>
           <a:p>
@@ -4813,7 +4813,7 @@
                 </a:solidFill>
                 <a:latin typeface="Calibri"/>
               </a:rPr>
-              <a:t>Takeaway — </a:t>
+              <a:t>Takeaway: </a:t>
             </a:r>
             <a:r>
               <a:rPr sz="1350" b="0">
@@ -4955,7 +4955,7 @@
                 </a:solidFill>
                 <a:latin typeface="Calibri"/>
               </a:rPr>
-              <a:t>Event counts per window are over-dispersed (Fano 1.3–1.6 vs the model’s 1.0) while the stress released per window is less variable (CV 0.10 vs 0.13)</a:t>
+              <a:t>Event counts per window are over-dispersed (Fano 1.3 to 1.6 vs the model’s 1.0) while the stress released per window is less variable (CV 0.10 vs 0.13)</a:t>
             </a:r>
           </a:p>
           <a:p>
@@ -4972,7 +4972,7 @@
                 </a:solidFill>
                 <a:latin typeface="Calibri"/>
               </a:rPr>
-              <a:t>Referenced to the last large event, the large-event hazard is 1.5× higher after 0.1–0.3 of reloading; large events are more regular (Fano 0.51 vs 0.71)</a:t>
+              <a:t>Referenced to the last large event, the large-event hazard is 1.5× higher after 0.1 to 0.3 of reloading; large events are more regular (Fano 0.51 vs 0.71)</a:t>
             </a:r>
           </a:p>
         </p:txBody>
@@ -5027,7 +5027,7 @@
                 </a:solidFill>
                 <a:latin typeface="Calibri"/>
               </a:rPr>
-              <a:t>Takeaway — </a:t>
+              <a:t>Takeaway: </a:t>
             </a:r>
             <a:r>
               <a:rPr sz="1350" b="0">
@@ -5151,7 +5151,7 @@
                 </a:solidFill>
                 <a:latin typeface="Calibri"/>
               </a:rPr>
-              <a:t>Run-to-run scatter within a preparation: model 25–30% too high</a:t>
+              <a:t>Run-to-run scatter within a preparation: model 25 to 30% too high</a:t>
             </a:r>
           </a:p>
           <a:p>
@@ -5185,7 +5185,7 @@
                 </a:solidFill>
                 <a:latin typeface="Calibri"/>
               </a:rPr>
-              <a:t>Not size–reload coupling (+0.02), size–size coupling (−0.01), relaxation rate (identical), the per-sample slow variable, or the u-channel noise terms</a:t>
+              <a:t>Not size-reload coupling (+0.02), size-size coupling (−0.01), relaxation rate (identical), the per-sample slow variable, or the u-channel noise terms</a:t>
             </a:r>
           </a:p>
         </p:txBody>
@@ -5259,7 +5259,7 @@
                 </a:solidFill>
                 <a:latin typeface="Calibri"/>
               </a:rPr>
-              <a:t>Closing it needs a per-step observable that is not (u,τ) — the same MD output the third variable asks for</a:t>
+              <a:t>Closing it needs a per-step observable that is not (u,τ), the same MD output the third variable asks for</a:t>
             </a:r>
           </a:p>
         </p:txBody>
@@ -5314,7 +5314,7 @@
                 </a:solidFill>
                 <a:latin typeface="Calibri"/>
               </a:rPr>
-              <a:t>Takeaway — </a:t>
+              <a:t>Takeaway: </a:t>
             </a:r>
             <a:r>
               <a:rPr sz="1350" b="0">
@@ -5500,7 +5500,7 @@
                 </a:solidFill>
                 <a:latin typeface="Calibri"/>
               </a:rPr>
-              <a:t>Stress–strain curves and yield peaks across 256× in cooling rate at the few-% level</a:t>
+              <a:t>Stress-strain curves and yield peaks across 256× in cooling rate at the few-% level</a:t>
             </a:r>
           </a:p>
           <a:p>
@@ -5642,7 +5642,7 @@
                 </a:solidFill>
                 <a:latin typeface="Calibri"/>
               </a:rPr>
-              <a:t>Convergence of preparations at large strain — the model’s opinion, now with a measured rate but no data past γ = 0.5</a:t>
+              <a:t>Convergence of preparations at large strain: the model predicts it, now with a measured rate, but there is no data past γ = 0.5</a:t>
             </a:r>
           </a:p>
           <a:p>
@@ -5733,7 +5733,7 @@
                 </a:solidFill>
                 <a:latin typeface="Calibri"/>
               </a:rPr>
-              <a:t>(u,τ) as a sufficient state — the 1.71× ceiling memory and the 5×-underpredicted u-spread, independently</a:t>
+              <a:t>(u,τ) as a sufficient state: the 1.71× ceiling memory and the 5×-underpredicted u-spread, independently</a:t>
             </a:r>
           </a:p>
           <a:p>
@@ -5750,7 +5750,7 @@
                 </a:solidFill>
                 <a:latin typeface="Calibri"/>
               </a:rPr>
-              <a:t>The step process as Markov in (u,τ) at the 10⁻⁵ strain scale — aftershocks (×20), reload-dependent large events</a:t>
+              <a:t>The step process as Markov in (u,τ) at the 10⁻⁵ strain scale: aftershocks (×20), reload-dependent large events</a:t>
             </a:r>
           </a:p>
           <a:p>
@@ -5839,7 +5839,7 @@
                 </a:solidFill>
                 <a:latin typeface="Calibri"/>
               </a:rPr>
-              <a:t>Takeaway — </a:t>
+              <a:t>Takeaway: </a:t>
             </a:r>
             <a:r>
               <a:rPr sz="1350" b="0">
@@ -6270,7 +6270,7 @@
                 </a:solidFill>
                 <a:latin typeface="Calibri"/>
               </a:rPr>
-              <a:t>Per step: strain, stress, potential energy, cooling rate — nothing else is recorded</a:t>
+              <a:t>Per step: strain, stress, potential energy, cooling rate. Nothing else is recorded</a:t>
             </a:r>
           </a:p>
         </p:txBody>
@@ -6360,7 +6360,7 @@
                 </a:solidFill>
                 <a:latin typeface="Calibri"/>
               </a:rPr>
-              <a:t>22 × 22 grid on (u,τ): inner 20 × 20 on the 0.2–99.8% quantiles plus a catch-all ring</a:t>
+              <a:t>22 × 22 grid on (u,τ): inner 20 × 20 on the 0.2 to 99.8% quantiles plus a catch-all ring</a:t>
             </a:r>
           </a:p>
         </p:txBody>
@@ -6415,7 +6415,7 @@
                 </a:solidFill>
                 <a:latin typeface="Calibri"/>
               </a:rPr>
-              <a:t>Takeaway — </a:t>
+              <a:t>Takeaway: </a:t>
             </a:r>
             <a:r>
               <a:rPr sz="1350" b="0">
@@ -6424,7 +6424,7 @@
                 </a:solidFill>
                 <a:latin typeface="Calibri"/>
               </a:rPr>
-              <a:t>The target this time is the probability distribution of yield events, P(s | u,τ) — discovered, not assumed — and everything downstream is rebuilt from it.</a:t>
+              <a:t>The target this time is the probability distribution of yield events, P(s | u,τ), with its form discovered rather than assumed, and everything downstream is rebuilt from it.</a:t>
             </a:r>
           </a:p>
         </p:txBody>
@@ -6868,7 +6868,7 @@
                 </a:solidFill>
                 <a:latin typeface="Calibri"/>
               </a:rPr>
-              <a:t>unchanged from the first pass — parity test for a back-stress variable</a:t>
+              <a:t>unchanged from the first pass; a parity test for a back-stress variable</a:t>
             </a:r>
           </a:p>
         </p:txBody>
@@ -6966,7 +6966,7 @@
                 </a:solidFill>
                 <a:latin typeface="Calibri"/>
               </a:rPr>
-              <a:t>the ceiling law with the one-parameter preparation memory and the aftershock hazard — the yield strength of a glass from its preparation history, to a few percent</a:t>
+              <a:t>the ceiling law with the one-parameter preparation memory and the aftershock hazard: the yield strength of a glass from its preparation history, to a few percent</a:t>
             </a:r>
           </a:p>
         </p:txBody>
@@ -7021,7 +7021,7 @@
                 </a:solidFill>
                 <a:latin typeface="Calibri"/>
               </a:rPr>
-              <a:t>Takeaway — </a:t>
+              <a:t>Takeaway: </a:t>
             </a:r>
             <a:r>
               <a:rPr sz="1350" b="0">
@@ -7030,7 +7030,7 @@
                 </a:solidFill>
                 <a:latin typeface="Calibri"/>
               </a:rPr>
-              <a:t>Everything here is regenerated from the raw data by pipeline/run_all.sh (43 min); Figures 1–22 and the README carry the details.</a:t>
+              <a:t>Everything here is regenerated from the raw data by pipeline/run_all.sh (43 min); Figures 1 to 22 and the README carry the details.</a:t>
             </a:r>
           </a:p>
         </p:txBody>
@@ -7262,7 +7262,7 @@
                 </a:solidFill>
                 <a:latin typeface="Calibri"/>
               </a:rPr>
-              <a:t>Everything downstream — mean sizes, the plastic-rate field q, full synthetic stress–strain curves — is then derived from the fitted law and compared with its measured counterpart</a:t>
+              <a:t>Everything downstream (mean sizes, the plastic-rate field q, full synthetic stress-strain curves) is then derived from the fitted law and compared with its measured counterpart</a:t>
             </a:r>
           </a:p>
         </p:txBody>
@@ -7317,7 +7317,7 @@
                 </a:solidFill>
                 <a:latin typeface="Calibri"/>
               </a:rPr>
-              <a:t>Takeaway — </a:t>
+              <a:t>Takeaway: </a:t>
             </a:r>
             <a:r>
               <a:rPr sz="1350" b="0">
@@ -7451,7 +7451,7 @@
                 </a:solidFill>
                 <a:latin typeface="Calibri"/>
               </a:rPr>
-              <a:t>Up to two constants fitted inside the nonlinearity (Levenberg–Marquardt, 4 restarts); outer affine profiled out</a:t>
+              <a:t>Up to two constants fitted inside the nonlinearity (Levenberg-Marquardt, 4 restarts); outer affine profiled out</a:t>
             </a:r>
           </a:p>
           <a:p>
@@ -7558,7 +7558,7 @@
                 </a:solidFill>
                 <a:latin typeface="Calibri"/>
               </a:rPr>
-              <a:t>12 cells (700–7,600 events) spanning the plane, plus unweighted-bin and wider-window variants</a:t>
+              <a:t>12 cells (700 to 7,600 events) spanning the plane, plus unweighted-bin and wider-window variants</a:t>
             </a:r>
           </a:p>
           <a:p>
@@ -7575,7 +7575,7 @@
                 </a:solidFill>
                 <a:latin typeface="Calibri"/>
               </a:rPr>
-              <a:t>Audit: the largest cell pushed to complexity 9 — 4,505,024 trees, 48,725 admissible — no new form appears</a:t>
+              <a:t>Audit: the largest cell pushed to complexity 9 (4,505,024 trees, 48,725 admissible); no new form appears</a:t>
             </a:r>
           </a:p>
           <a:p>
@@ -7592,7 +7592,7 @@
                 </a:solidFill>
                 <a:latin typeface="Calibri"/>
               </a:rPr>
-              <a:t>SR proposes; the likelihood disposes (next slides)</a:t>
+              <a:t>The search proposes forms; a per-event likelihood chooses among them (next slides)</a:t>
             </a:r>
           </a:p>
         </p:txBody>
@@ -7647,7 +7647,7 @@
                 </a:solidFill>
                 <a:latin typeface="Calibri"/>
               </a:rPr>
-              <a:t>Takeaway — </a:t>
+              <a:t>Takeaway: </a:t>
             </a:r>
             <a:r>
               <a:rPr sz="1350" b="0">
@@ -7823,7 +7823,7 @@
                 </a:solidFill>
                 <a:latin typeface="Calibri"/>
               </a:rPr>
-              <a:t>s_c(u,τ): a hard ceiling — the largest event the state can produce; the density vanishes like (s_c − s)ᵐ, m ≈ 2.3</a:t>
+              <a:t>s_c(u,τ): a hard ceiling, the largest event the state can produce; the density vanishes like (s_c − s)ᵐ, m ≈ 2.3</a:t>
             </a:r>
           </a:p>
           <a:p>
@@ -7895,7 +7895,7 @@
                 </a:solidFill>
                 <a:latin typeface="Calibri"/>
               </a:rPr>
-              <a:t>Takeaway — </a:t>
+              <a:t>Takeaway: </a:t>
             </a:r>
             <a:r>
               <a:rPr sz="1350" b="0">
@@ -8093,7 +8093,7 @@
                 </a:solidFill>
                 <a:latin typeface="Calibri"/>
               </a:rPr>
-              <a:t>Takeaway — </a:t>
+              <a:t>Takeaway: </a:t>
             </a:r>
             <a:r>
               <a:rPr sz="1350" b="0">
@@ -8154,7 +8154,7 @@
                 </a:solidFill>
                 <a:latin typeface="Calibri"/>
               </a:rPr>
-              <a:t>SR proposes, the likelihood disposes</a:t>
+              <a:t>The likelihood chooses among the candidate forms</a:t>
             </a:r>
           </a:p>
         </p:txBody>
@@ -8235,7 +8235,7 @@
                 </a:solidFill>
                 <a:latin typeface="Calibri"/>
               </a:rPr>
-              <a:t>The ceiling law wins 8 of 8 large cells: ΔAIC 67–120 over the TPL, 300–754 over the lognormal</a:t>
+              <a:t>The ceiling law wins 8 of 8 large cells: ΔAIC 67 to 120 over the TPL, 300 to 754 over the lognormal</a:t>
             </a:r>
           </a:p>
           <a:p>
@@ -8341,7 +8341,7 @@
                 </a:solidFill>
                 <a:latin typeface="Calibri"/>
               </a:rPr>
-              <a:t>Takeaway — </a:t>
+              <a:t>Takeaway: </a:t>
             </a:r>
             <a:r>
               <a:rPr sz="1350" b="0">
@@ -8350,7 +8350,7 @@
                 </a:solidFill>
                 <a:latin typeface="Calibri"/>
               </a:rPr>
-              <a:t>The bounded-support law is decided by per-event likelihood with falsifiability controls, not by the binned fit.</a:t>
+              <a:t>Per-event likelihood with falsifiability controls decides for the bounded-support law; the binned fit only proposed it.</a:t>
             </a:r>
           </a:p>
         </p:txBody>
@@ -8484,7 +8484,7 @@
                 </a:solidFill>
                 <a:latin typeface="Calibri"/>
               </a:rPr>
-              <a:t>Left: 277 cells, 146× in range (0.02 cold → 3.0 in the flowing state), bootstrap error 6.5%; rank-1 factorization Λ(u)·f(τ) carries 95.5% of the log-variance.  Right: refit by preparation at fixed cell — slow-cooled glass has a 1.71× higher ceiling than fast-cooled.</a:t>
+              <a:t>Left: 277 cells, 146× in range (0.02 cold → 3.0 in the flowing state), bootstrap error 6.5%; rank-1 factorization Λ(u)·f(τ) carries 95.5% of the log-variance.  Right: refit by preparation at fixed cell; slow-cooled glass has a 1.71× higher ceiling than fast-cooled.</a:t>
             </a:r>
           </a:p>
         </p:txBody>
@@ -8539,7 +8539,7 @@
                 </a:solidFill>
                 <a:latin typeface="Calibri"/>
               </a:rPr>
-              <a:t>Takeaway — </a:t>
+              <a:t>Takeaway: </a:t>
             </a:r>
             <a:r>
               <a:rPr sz="1350" b="0">
@@ -8548,7 +8548,7 @@
                 </a:solidFill>
                 <a:latin typeface="Calibri"/>
               </a:rPr>
-              <a:t>All state dependence, and all preparation memory, sit in one parameter — the ceiling.</a:t>
+              <a:t>All state dependence, and all preparation memory, sit in one parameter: the ceiling.</a:t>
             </a:r>
           </a:p>
         </p:txBody>
@@ -8698,7 +8698,7 @@
                 </a:solidFill>
                 <a:latin typeface="Calibri"/>
               </a:rPr>
-              <a:t>Agreement: median +1.8%, RMS 17% against a 17.5% split-half noise floor — the test is saturated</a:t>
+              <a:t>Agreement: median +1.8%, RMS 17% against a 17.5% split-half noise floor; the test is saturated</a:t>
             </a:r>
           </a:p>
           <a:p>
@@ -8787,7 +8787,7 @@
                 </a:solidFill>
                 <a:latin typeface="Calibri"/>
               </a:rPr>
-              <a:t>Takeaway — </a:t>
+              <a:t>Takeaway: </a:t>
             </a:r>
             <a:r>
               <a:rPr sz="1350" b="0">

</xml_diff>